<commit_message>
pridané moduly zo SRWE
</commit_message>
<xml_diff>
--- a/ITN_Module_16.pptx
+++ b/ITN_Module_16.pptx
@@ -217,254 +217,27 @@
 </p:cmAuthorLst>
 </file>
 
-<file path=ppt/revisionInfo.xml><?xml version="1.0" encoding="utf-8"?>
-<p1510:revInfo xmlns:a="http://schemas.openxmlformats.org/drawingml/2006/main" xmlns:r="http://schemas.openxmlformats.org/officeDocument/2006/relationships" xmlns:p1510="http://schemas.microsoft.com/office/powerpoint/2015/10/main">
-  <p1510:revLst>
-    <p1510:client id="{8AFC1F52-A0CF-694B-A037-A7B3AC3B4F24}" v="2" dt="2022-04-25T06:37:57.985"/>
-  </p1510:revLst>
-</p1510:revInfo>
-</file>
-
 <file path=ppt/changesInfos/changesInfo1.xml><?xml version="1.0" encoding="utf-8"?>
 <pc:chgInfo xmlns:a="http://schemas.openxmlformats.org/drawingml/2006/main" xmlns:r="http://schemas.openxmlformats.org/officeDocument/2006/relationships" xmlns:ac="http://schemas.microsoft.com/office/drawing/2013/main/command" xmlns:pc="http://schemas.microsoft.com/office/powerpoint/2013/main/command">
   <pc:docChgLst>
-    <pc:chgData name="Július Baráth" userId="e650c4ab-697e-4750-bd58-c1531aabce95" providerId="ADAL" clId="{21EDF5CF-B8DB-2A4F-8866-A2E0FF5EBBC7}"/>
-    <pc:docChg chg="undo addSld delSld">
-      <pc:chgData name="Július Baráth" userId="e650c4ab-697e-4750-bd58-c1531aabce95" providerId="ADAL" clId="{21EDF5CF-B8DB-2A4F-8866-A2E0FF5EBBC7}" dt="2020-01-20T11:57:02.394" v="23" actId="2696"/>
-      <pc:docMkLst>
-        <pc:docMk/>
-      </pc:docMkLst>
-      <pc:sldChg chg="add del">
-        <pc:chgData name="Július Baráth" userId="e650c4ab-697e-4750-bd58-c1531aabce95" providerId="ADAL" clId="{21EDF5CF-B8DB-2A4F-8866-A2E0FF5EBBC7}" dt="2020-01-20T11:57:02.394" v="23" actId="2696"/>
-        <pc:sldMkLst>
-          <pc:docMk/>
-          <pc:sldMk cId="4190828277" sldId="291"/>
-        </pc:sldMkLst>
-      </pc:sldChg>
-      <pc:sldChg chg="del">
-        <pc:chgData name="Július Baráth" userId="e650c4ab-697e-4750-bd58-c1531aabce95" providerId="ADAL" clId="{21EDF5CF-B8DB-2A4F-8866-A2E0FF5EBBC7}" dt="2020-01-20T11:56:18.209" v="0" actId="2696"/>
-        <pc:sldMkLst>
-          <pc:docMk/>
-          <pc:sldMk cId="111192384" sldId="860"/>
-        </pc:sldMkLst>
-      </pc:sldChg>
-      <pc:sldChg chg="del">
-        <pc:chgData name="Július Baráth" userId="e650c4ab-697e-4750-bd58-c1531aabce95" providerId="ADAL" clId="{21EDF5CF-B8DB-2A4F-8866-A2E0FF5EBBC7}" dt="2020-01-20T11:56:45.126" v="10" actId="2696"/>
-        <pc:sldMkLst>
-          <pc:docMk/>
-          <pc:sldMk cId="3271745509" sldId="874"/>
-        </pc:sldMkLst>
-      </pc:sldChg>
-      <pc:sldChg chg="del">
-        <pc:chgData name="Július Baráth" userId="e650c4ab-697e-4750-bd58-c1531aabce95" providerId="ADAL" clId="{21EDF5CF-B8DB-2A4F-8866-A2E0FF5EBBC7}" dt="2020-01-20T11:56:41.223" v="4" actId="2696"/>
-        <pc:sldMkLst>
-          <pc:docMk/>
-          <pc:sldMk cId="410599242" sldId="957"/>
-        </pc:sldMkLst>
-      </pc:sldChg>
-      <pc:sldChg chg="del">
-        <pc:chgData name="Július Baráth" userId="e650c4ab-697e-4750-bd58-c1531aabce95" providerId="ADAL" clId="{21EDF5CF-B8DB-2A4F-8866-A2E0FF5EBBC7}" dt="2020-01-20T11:56:42.309" v="5" actId="2696"/>
-        <pc:sldMkLst>
-          <pc:docMk/>
-          <pc:sldMk cId="2548999575" sldId="958"/>
-        </pc:sldMkLst>
-      </pc:sldChg>
-      <pc:sldChg chg="add del">
-        <pc:chgData name="Július Baráth" userId="e650c4ab-697e-4750-bd58-c1531aabce95" providerId="ADAL" clId="{21EDF5CF-B8DB-2A4F-8866-A2E0FF5EBBC7}" dt="2020-01-20T11:56:59.211" v="18" actId="2696"/>
-        <pc:sldMkLst>
-          <pc:docMk/>
-          <pc:sldMk cId="647621406" sldId="1118"/>
-        </pc:sldMkLst>
-      </pc:sldChg>
-      <pc:sldChg chg="del">
-        <pc:chgData name="Július Baráth" userId="e650c4ab-697e-4750-bd58-c1531aabce95" providerId="ADAL" clId="{21EDF5CF-B8DB-2A4F-8866-A2E0FF5EBBC7}" dt="2020-01-20T11:56:24.226" v="1" actId="2696"/>
-        <pc:sldMkLst>
-          <pc:docMk/>
-          <pc:sldMk cId="1269657643" sldId="1124"/>
-        </pc:sldMkLst>
-      </pc:sldChg>
-      <pc:sldChg chg="add del">
-        <pc:chgData name="Július Baráth" userId="e650c4ab-697e-4750-bd58-c1531aabce95" providerId="ADAL" clId="{21EDF5CF-B8DB-2A4F-8866-A2E0FF5EBBC7}" dt="2020-01-20T11:56:59.567" v="19" actId="2696"/>
-        <pc:sldMkLst>
-          <pc:docMk/>
-          <pc:sldMk cId="3376162931" sldId="1131"/>
-        </pc:sldMkLst>
-      </pc:sldChg>
-      <pc:sldChg chg="add del">
-        <pc:chgData name="Július Baráth" userId="e650c4ab-697e-4750-bd58-c1531aabce95" providerId="ADAL" clId="{21EDF5CF-B8DB-2A4F-8866-A2E0FF5EBBC7}" dt="2020-01-20T11:57:00.128" v="20" actId="2696"/>
-        <pc:sldMkLst>
-          <pc:docMk/>
-          <pc:sldMk cId="1392835321" sldId="1132"/>
-        </pc:sldMkLst>
-      </pc:sldChg>
-      <pc:sldChg chg="add del">
-        <pc:chgData name="Július Baráth" userId="e650c4ab-697e-4750-bd58-c1531aabce95" providerId="ADAL" clId="{21EDF5CF-B8DB-2A4F-8866-A2E0FF5EBBC7}" dt="2020-01-20T11:57:00.906" v="21" actId="2696"/>
-        <pc:sldMkLst>
-          <pc:docMk/>
-          <pc:sldMk cId="1658387370" sldId="1133"/>
-        </pc:sldMkLst>
-      </pc:sldChg>
-      <pc:sldChg chg="add del">
-        <pc:chgData name="Július Baráth" userId="e650c4ab-697e-4750-bd58-c1531aabce95" providerId="ADAL" clId="{21EDF5CF-B8DB-2A4F-8866-A2E0FF5EBBC7}" dt="2020-01-20T11:57:01.680" v="22" actId="2696"/>
-        <pc:sldMkLst>
-          <pc:docMk/>
-          <pc:sldMk cId="1874210689" sldId="1134"/>
-        </pc:sldMkLst>
-      </pc:sldChg>
-      <pc:sldChg chg="del">
-        <pc:chgData name="Július Baráth" userId="e650c4ab-697e-4750-bd58-c1531aabce95" providerId="ADAL" clId="{21EDF5CF-B8DB-2A4F-8866-A2E0FF5EBBC7}" dt="2020-01-20T11:56:37.865" v="2" actId="2696"/>
-        <pc:sldMkLst>
-          <pc:docMk/>
-          <pc:sldMk cId="3695759580" sldId="1135"/>
-        </pc:sldMkLst>
-      </pc:sldChg>
-      <pc:sldChg chg="del">
-        <pc:chgData name="Július Baráth" userId="e650c4ab-697e-4750-bd58-c1531aabce95" providerId="ADAL" clId="{21EDF5CF-B8DB-2A4F-8866-A2E0FF5EBBC7}" dt="2020-01-20T11:56:38.737" v="3" actId="2696"/>
-        <pc:sldMkLst>
-          <pc:docMk/>
-          <pc:sldMk cId="3735334095" sldId="1136"/>
-        </pc:sldMkLst>
-      </pc:sldChg>
-      <pc:sldChg chg="del">
-        <pc:chgData name="Július Baráth" userId="e650c4ab-697e-4750-bd58-c1531aabce95" providerId="ADAL" clId="{21EDF5CF-B8DB-2A4F-8866-A2E0FF5EBBC7}" dt="2020-01-20T11:56:43.497" v="7" actId="2696"/>
-        <pc:sldMkLst>
-          <pc:docMk/>
-          <pc:sldMk cId="1531376889" sldId="1137"/>
-        </pc:sldMkLst>
-      </pc:sldChg>
-      <pc:sldChg chg="del">
-        <pc:chgData name="Július Baráth" userId="e650c4ab-697e-4750-bd58-c1531aabce95" providerId="ADAL" clId="{21EDF5CF-B8DB-2A4F-8866-A2E0FF5EBBC7}" dt="2020-01-20T11:56:43.979" v="8" actId="2696"/>
-        <pc:sldMkLst>
-          <pc:docMk/>
-          <pc:sldMk cId="2929623157" sldId="1138"/>
-        </pc:sldMkLst>
-      </pc:sldChg>
-      <pc:sldChg chg="del">
-        <pc:chgData name="Július Baráth" userId="e650c4ab-697e-4750-bd58-c1531aabce95" providerId="ADAL" clId="{21EDF5CF-B8DB-2A4F-8866-A2E0FF5EBBC7}" dt="2020-01-20T11:56:42.878" v="6" actId="2696"/>
-        <pc:sldMkLst>
-          <pc:docMk/>
-          <pc:sldMk cId="2375646353" sldId="1139"/>
-        </pc:sldMkLst>
-      </pc:sldChg>
-      <pc:sldChg chg="del">
-        <pc:chgData name="Július Baráth" userId="e650c4ab-697e-4750-bd58-c1531aabce95" providerId="ADAL" clId="{21EDF5CF-B8DB-2A4F-8866-A2E0FF5EBBC7}" dt="2020-01-20T11:56:44.463" v="9" actId="2696"/>
-        <pc:sldMkLst>
-          <pc:docMk/>
-          <pc:sldMk cId="783294431" sldId="1141"/>
-        </pc:sldMkLst>
-      </pc:sldChg>
-      <pc:sldMasterChg chg="delSldLayout">
-        <pc:chgData name="Július Baráth" userId="e650c4ab-697e-4750-bd58-c1531aabce95" providerId="ADAL" clId="{21EDF5CF-B8DB-2A4F-8866-A2E0FF5EBBC7}" dt="2020-01-20T11:56:45.128" v="11" actId="2696"/>
-        <pc:sldMasterMkLst>
-          <pc:docMk/>
-          <pc:sldMasterMk cId="0" sldId="2147483700"/>
-        </pc:sldMasterMkLst>
-        <pc:sldLayoutChg chg="del">
-          <pc:chgData name="Július Baráth" userId="e650c4ab-697e-4750-bd58-c1531aabce95" providerId="ADAL" clId="{21EDF5CF-B8DB-2A4F-8866-A2E0FF5EBBC7}" dt="2020-01-20T11:56:45.128" v="11" actId="2696"/>
-          <pc:sldLayoutMkLst>
-            <pc:docMk/>
-            <pc:sldMasterMk cId="0" sldId="2147483700"/>
-            <pc:sldLayoutMk cId="2257996623" sldId="2147484029"/>
-          </pc:sldLayoutMkLst>
-        </pc:sldLayoutChg>
-      </pc:sldMasterChg>
-    </pc:docChg>
-  </pc:docChgLst>
-  <pc:docChgLst>
-    <pc:chgData name="Július Baráth" userId="e650c4ab-697e-4750-bd58-c1531aabce95" providerId="ADAL" clId="{8AFC1F52-A0CF-694B-A037-A7B3AC3B4F24}"/>
-    <pc:docChg chg="custSel modSld">
-      <pc:chgData name="Július Baráth" userId="e650c4ab-697e-4750-bd58-c1531aabce95" providerId="ADAL" clId="{8AFC1F52-A0CF-694B-A037-A7B3AC3B4F24}" dt="2022-04-25T06:45:18.406" v="25" actId="20577"/>
+    <pc:chgData name="Baráth, Július" userId="aebde9b9-dccc-4475-a9ac-c05e78323d7a" providerId="ADAL" clId="{4A0811C8-ED2F-505E-B787-C8270CED5046}"/>
+    <pc:docChg chg="modSld">
+      <pc:chgData name="Baráth, Július" userId="aebde9b9-dccc-4475-a9ac-c05e78323d7a" providerId="ADAL" clId="{4A0811C8-ED2F-505E-B787-C8270CED5046}" dt="2026-05-05T07:34:53.801" v="0" actId="1076"/>
       <pc:docMkLst>
         <pc:docMk/>
       </pc:docMkLst>
       <pc:sldChg chg="modSp mod">
-        <pc:chgData name="Július Baráth" userId="e650c4ab-697e-4750-bd58-c1531aabce95" providerId="ADAL" clId="{8AFC1F52-A0CF-694B-A037-A7B3AC3B4F24}" dt="2022-04-25T06:45:18.406" v="25" actId="20577"/>
+        <pc:chgData name="Baráth, Július" userId="aebde9b9-dccc-4475-a9ac-c05e78323d7a" providerId="ADAL" clId="{4A0811C8-ED2F-505E-B787-C8270CED5046}" dt="2026-05-05T07:34:53.801" v="0" actId="1076"/>
         <pc:sldMkLst>
           <pc:docMk/>
-          <pc:sldMk cId="647621406" sldId="1118"/>
+          <pc:sldMk cId="4176667935" sldId="1129"/>
         </pc:sldMkLst>
         <pc:spChg chg="mod">
-          <ac:chgData name="Július Baráth" userId="e650c4ab-697e-4750-bd58-c1531aabce95" providerId="ADAL" clId="{8AFC1F52-A0CF-694B-A037-A7B3AC3B4F24}" dt="2022-04-25T06:45:18.406" v="25" actId="20577"/>
+          <ac:chgData name="Baráth, Július" userId="aebde9b9-dccc-4475-a9ac-c05e78323d7a" providerId="ADAL" clId="{4A0811C8-ED2F-505E-B787-C8270CED5046}" dt="2026-05-05T07:34:53.801" v="0" actId="1076"/>
           <ac:spMkLst>
             <pc:docMk/>
-            <pc:sldMk cId="647621406" sldId="1118"/>
-            <ac:spMk id="5" creationId="{58ED2B98-3FC5-0547-B3D3-64215AA81FB7}"/>
-          </ac:spMkLst>
-        </pc:spChg>
-      </pc:sldChg>
-      <pc:sldChg chg="modSp mod">
-        <pc:chgData name="Július Baráth" userId="e650c4ab-697e-4750-bd58-c1531aabce95" providerId="ADAL" clId="{8AFC1F52-A0CF-694B-A037-A7B3AC3B4F24}" dt="2022-04-25T06:13:40.668" v="3" actId="27636"/>
-        <pc:sldMkLst>
-          <pc:docMk/>
-          <pc:sldMk cId="1528713480" sldId="1119"/>
-        </pc:sldMkLst>
-        <pc:spChg chg="mod">
-          <ac:chgData name="Július Baráth" userId="e650c4ab-697e-4750-bd58-c1531aabce95" providerId="ADAL" clId="{8AFC1F52-A0CF-694B-A037-A7B3AC3B4F24}" dt="2022-04-25T06:13:40.668" v="3" actId="27636"/>
-          <ac:spMkLst>
-            <pc:docMk/>
-            <pc:sldMk cId="1528713480" sldId="1119"/>
-            <ac:spMk id="5" creationId="{FA41A9FF-8CDE-E44C-BE13-FAE40B97A3EE}"/>
-          </ac:spMkLst>
-        </pc:spChg>
-      </pc:sldChg>
-      <pc:sldChg chg="addSp modSp mod">
-        <pc:chgData name="Július Baráth" userId="e650c4ab-697e-4750-bd58-c1531aabce95" providerId="ADAL" clId="{8AFC1F52-A0CF-694B-A037-A7B3AC3B4F24}" dt="2022-04-25T06:38:44.604" v="19" actId="1076"/>
-        <pc:sldMkLst>
-          <pc:docMk/>
-          <pc:sldMk cId="2667065313" sldId="1126"/>
-        </pc:sldMkLst>
-        <pc:picChg chg="add mod">
-          <ac:chgData name="Július Baráth" userId="e650c4ab-697e-4750-bd58-c1531aabce95" providerId="ADAL" clId="{8AFC1F52-A0CF-694B-A037-A7B3AC3B4F24}" dt="2022-04-25T06:38:44.604" v="19" actId="1076"/>
-          <ac:picMkLst>
-            <pc:docMk/>
-            <pc:sldMk cId="2667065313" sldId="1126"/>
-            <ac:picMk id="2" creationId="{08BFE416-B7D8-A94E-8705-014539BE7988}"/>
-          </ac:picMkLst>
-        </pc:picChg>
-        <pc:picChg chg="add mod">
-          <ac:chgData name="Július Baráth" userId="e650c4ab-697e-4750-bd58-c1531aabce95" providerId="ADAL" clId="{8AFC1F52-A0CF-694B-A037-A7B3AC3B4F24}" dt="2022-04-25T06:38:38.423" v="18" actId="1076"/>
-          <ac:picMkLst>
-            <pc:docMk/>
-            <pc:sldMk cId="2667065313" sldId="1126"/>
-            <ac:picMk id="5" creationId="{1BAFF858-C831-7240-96E2-37B96A0B4662}"/>
-          </ac:picMkLst>
-        </pc:picChg>
-        <pc:picChg chg="mod">
-          <ac:chgData name="Július Baráth" userId="e650c4ab-697e-4750-bd58-c1531aabce95" providerId="ADAL" clId="{8AFC1F52-A0CF-694B-A037-A7B3AC3B4F24}" dt="2022-04-25T06:38:36.533" v="17" actId="1076"/>
-          <ac:picMkLst>
-            <pc:docMk/>
-            <pc:sldMk cId="2667065313" sldId="1126"/>
-            <ac:picMk id="8" creationId="{CA3B1276-4D3A-B546-B0D3-54E99AE89A64}"/>
-          </ac:picMkLst>
-        </pc:picChg>
-      </pc:sldChg>
-      <pc:sldChg chg="modSp mod">
-        <pc:chgData name="Július Baráth" userId="e650c4ab-697e-4750-bd58-c1531aabce95" providerId="ADAL" clId="{8AFC1F52-A0CF-694B-A037-A7B3AC3B4F24}" dt="2022-04-25T06:42:37.080" v="20" actId="1036"/>
-        <pc:sldMkLst>
-          <pc:docMk/>
-          <pc:sldMk cId="2089573737" sldId="1128"/>
-        </pc:sldMkLst>
-        <pc:picChg chg="mod">
-          <ac:chgData name="Július Baráth" userId="e650c4ab-697e-4750-bd58-c1531aabce95" providerId="ADAL" clId="{8AFC1F52-A0CF-694B-A037-A7B3AC3B4F24}" dt="2022-04-25T06:42:37.080" v="20" actId="1036"/>
-          <ac:picMkLst>
-            <pc:docMk/>
-            <pc:sldMk cId="2089573737" sldId="1128"/>
-            <ac:picMk id="12" creationId="{CD80D756-D9AD-BB4E-8C8D-FF29770DE996}"/>
-          </ac:picMkLst>
-        </pc:picChg>
-      </pc:sldChg>
-      <pc:sldChg chg="modSp mod">
-        <pc:chgData name="Július Baráth" userId="e650c4ab-697e-4750-bd58-c1531aabce95" providerId="ADAL" clId="{8AFC1F52-A0CF-694B-A037-A7B3AC3B4F24}" dt="2022-04-25T06:45:08.759" v="21" actId="27636"/>
-        <pc:sldMkLst>
-          <pc:docMk/>
-          <pc:sldMk cId="3376162931" sldId="1131"/>
-        </pc:sldMkLst>
-        <pc:spChg chg="mod">
-          <ac:chgData name="Július Baráth" userId="e650c4ab-697e-4750-bd58-c1531aabce95" providerId="ADAL" clId="{8AFC1F52-A0CF-694B-A037-A7B3AC3B4F24}" dt="2022-04-25T06:45:08.759" v="21" actId="27636"/>
-          <ac:spMkLst>
-            <pc:docMk/>
-            <pc:sldMk cId="3376162931" sldId="1131"/>
-            <ac:spMk id="4" creationId="{6F289C2A-4C2A-774B-84F0-F2FF0A7AC295}"/>
+            <pc:sldMk cId="4176667935" sldId="1129"/>
+            <ac:spMk id="5" creationId="{56518DF6-F66A-404B-BAB8-473E33120000}"/>
           </ac:spMkLst>
         </pc:spChg>
       </pc:sldChg>
@@ -555,7 +328,7 @@
           <a:p>
             <a:fld id="{136337D9-3022-3D41-8D8A-BDF2F3B0DD8E}" type="datetimeFigureOut">
               <a:rPr lang="en-US" smtClean="0"/>
-              <a:t>4/25/22</a:t>
+              <a:t>5/5/26</a:t>
             </a:fld>
             <a:endParaRPr lang="en-US" dirty="0"/>
           </a:p>
@@ -27107,7 +26880,7 @@
         </p:nvSpPr>
         <p:spPr>
           <a:xfrm>
-            <a:off x="474662" y="763736"/>
+            <a:off x="538457" y="763736"/>
             <a:ext cx="8280057" cy="3657998"/>
           </a:xfrm>
         </p:spPr>

</xml_diff>